<commit_message>
Day 2 M2: slide 8 title tightened; slide 13 line trimmed
Slide 8: 'Semantic ranker — the quiet weapon' -> 'Semantic ranker'
  Drops the editorial subtitle; keeps the section anchor clean.

Slide 13: 'Source IQ doesn't yet connect to' -> 'Source IQ doesn't yet connect'
  Trailing 'to' left dangling grammatically; matches the wording of the
  facing 'IQ doesn't yet connect' bullet on the same slide.

Both edits applied in day2.js AND slides/day2/module-2-custom-rag.md so
the markdown source and the built deck stay in lockstep.

Rebuilt module-2-custom-rag.pptx (16 slides, unchanged).

Co-authored-by: Copilot <223556219+Copilot@users.noreply.github.com>
</commit_message>
<xml_diff>
--- a/decks/day2/module-2-custom-rag.pptx
+++ b/decks/day2/module-2-custom-rag.pptx
@@ -3845,7 +3845,7 @@
                 <a:ea typeface="Calibri" pitchFamily="34" charset="-122"/>
                 <a:cs typeface="Calibri" pitchFamily="34" charset="-120"/>
               </a:rPr>
-              <a:t>Source IQ doesn't yet connect to</a:t>
+              <a:t>Source IQ doesn't yet connect</a:t>
             </a:r>
             <a:endParaRPr lang="en-US" sz="1500" dirty="0"/>
           </a:p>
@@ -8442,7 +8442,7 @@
                 <a:ea typeface="Calibri" pitchFamily="34" charset="-122"/>
                 <a:cs typeface="Calibri" pitchFamily="34" charset="-120"/>
               </a:rPr>
-              <a:t>Semantic ranker — the quiet weapon</a:t>
+              <a:t>Semantic ranker</a:t>
             </a:r>
             <a:endParaRPr lang="en-US" sz="2800" dirty="0"/>
           </a:p>

</xml_diff>